<commit_message>
feat: finalize routed retrieval and RRF evaluation
</commit_message>
<xml_diff>
--- a/survey/调研报告汇报PPT_终稿版.pptx
+++ b/survey/调研报告汇报PPT_终稿版.pptx
@@ -5,26 +5,26 @@
     <p:sldMasterId id="2147483648" r:id="rId1"/>
   </p:sldMasterIdLst>
   <p:sldIdLst>
-    <p:sldId id="256" r:id="rId7"/>
-    <p:sldId id="257" r:id="rId8"/>
-    <p:sldId id="258" r:id="rId9"/>
-    <p:sldId id="259" r:id="rId10"/>
-    <p:sldId id="260" r:id="rId11"/>
-    <p:sldId id="261" r:id="rId12"/>
-    <p:sldId id="262" r:id="rId13"/>
-    <p:sldId id="263" r:id="rId14"/>
-    <p:sldId id="264" r:id="rId15"/>
-    <p:sldId id="265" r:id="rId16"/>
-    <p:sldId id="273" r:id="rId24"/>
-    <p:sldId id="266" r:id="rId17"/>
-    <p:sldId id="267" r:id="rId18"/>
-    <p:sldId id="268" r:id="rId19"/>
-    <p:sldId id="269" r:id="rId20"/>
-    <p:sldId id="270" r:id="rId21"/>
-    <p:sldId id="271" r:id="rId22"/>
-    <p:sldId id="272" r:id="rId23"/>
+    <p:sldId id="256" r:id="rId2"/>
+    <p:sldId id="257" r:id="rId3"/>
+    <p:sldId id="258" r:id="rId4"/>
+    <p:sldId id="259" r:id="rId5"/>
+    <p:sldId id="260" r:id="rId6"/>
+    <p:sldId id="261" r:id="rId7"/>
+    <p:sldId id="262" r:id="rId8"/>
+    <p:sldId id="263" r:id="rId9"/>
+    <p:sldId id="264" r:id="rId10"/>
+    <p:sldId id="265" r:id="rId11"/>
+    <p:sldId id="273" r:id="rId12"/>
+    <p:sldId id="266" r:id="rId13"/>
+    <p:sldId id="267" r:id="rId14"/>
+    <p:sldId id="268" r:id="rId15"/>
+    <p:sldId id="269" r:id="rId16"/>
+    <p:sldId id="270" r:id="rId17"/>
+    <p:sldId id="271" r:id="rId18"/>
+    <p:sldId id="272" r:id="rId19"/>
   </p:sldIdLst>
-  <p:sldSz cx="12191695" cy="6858000" type="screen4x3"/>
+  <p:sldSz cx="12192000" cy="6858000"/>
   <p:notesSz cx="6858000" cy="9144000"/>
   <p:defaultTextStyle>
     <a:defPPr>
@@ -121,6 +121,22 @@
       </a:defRPr>
     </a:lvl9pPr>
   </p:defaultTextStyle>
+  <p:extLst>
+    <p:ext uri="{EFAFB233-063F-42B5-8137-9DF3F51BA10A}">
+      <p15:sldGuideLst xmlns:p15="http://schemas.microsoft.com/office/powerpoint/2012/main">
+        <p15:guide id="1" orient="horz" pos="2160">
+          <p15:clr>
+            <a:srgbClr val="A4A3A4"/>
+          </p15:clr>
+        </p15:guide>
+        <p15:guide id="2" pos="2880">
+          <p15:clr>
+            <a:srgbClr val="A4A3A4"/>
+          </p15:clr>
+        </p15:guide>
+      </p15:sldGuideLst>
+    </p:ext>
+  </p:extLst>
 </p:presentation>
 </file>
 
@@ -162,10 +178,9 @@
           <a:lstStyle/>
           <a:p>
             <a:r>
-              <a:rPr lang="en-US" smtClean="0"/>
+              <a:rPr lang="en-US"/>
               <a:t>Click to edit Master title style</a:t>
             </a:r>
-            <a:endParaRPr lang="en-US"/>
           </a:p>
         </p:txBody>
       </p:sp>
@@ -281,10 +296,9 @@
           </a:lstStyle>
           <a:p>
             <a:r>
-              <a:rPr lang="en-US" smtClean="0"/>
+              <a:rPr lang="en-US"/>
               <a:t>Click to edit Master subtitle style</a:t>
             </a:r>
-            <a:endParaRPr lang="en-US"/>
           </a:p>
         </p:txBody>
       </p:sp>
@@ -305,7 +319,7 @@
           <a:p>
             <a:fld id="{5BCAD085-E8A6-8845-BD4E-CB4CCA059FC4}" type="datetimeFigureOut">
               <a:rPr lang="en-US" smtClean="0"/>
-              <a:t>1/27/13</a:t>
+              <a:t>9/20/2026</a:t>
             </a:fld>
             <a:endParaRPr lang="en-US"/>
           </a:p>
@@ -399,10 +413,9 @@
           <a:lstStyle/>
           <a:p>
             <a:r>
-              <a:rPr lang="en-US" smtClean="0"/>
+              <a:rPr lang="en-US"/>
               <a:t>Click to edit Master title style</a:t>
             </a:r>
-            <a:endParaRPr lang="en-US"/>
           </a:p>
         </p:txBody>
       </p:sp>
@@ -423,38 +436,37 @@
           <a:p>
             <a:pPr lvl="0"/>
             <a:r>
-              <a:rPr lang="en-US" smtClean="0"/>
+              <a:rPr lang="en-US"/>
               <a:t>Click to edit Master text styles</a:t>
             </a:r>
           </a:p>
           <a:p>
             <a:pPr lvl="1"/>
             <a:r>
-              <a:rPr lang="en-US" smtClean="0"/>
+              <a:rPr lang="en-US"/>
               <a:t>Second level</a:t>
             </a:r>
           </a:p>
           <a:p>
             <a:pPr lvl="2"/>
             <a:r>
-              <a:rPr lang="en-US" smtClean="0"/>
+              <a:rPr lang="en-US"/>
               <a:t>Third level</a:t>
             </a:r>
           </a:p>
           <a:p>
             <a:pPr lvl="3"/>
             <a:r>
-              <a:rPr lang="en-US" smtClean="0"/>
+              <a:rPr lang="en-US"/>
               <a:t>Fourth level</a:t>
             </a:r>
           </a:p>
           <a:p>
             <a:pPr lvl="4"/>
             <a:r>
-              <a:rPr lang="en-US" smtClean="0"/>
+              <a:rPr lang="en-US"/>
               <a:t>Fifth level</a:t>
             </a:r>
-            <a:endParaRPr lang="en-US"/>
           </a:p>
         </p:txBody>
       </p:sp>
@@ -475,7 +487,7 @@
           <a:p>
             <a:fld id="{5BCAD085-E8A6-8845-BD4E-CB4CCA059FC4}" type="datetimeFigureOut">
               <a:rPr lang="en-US" smtClean="0"/>
-              <a:t>1/27/13</a:t>
+              <a:t>9/20/2026</a:t>
             </a:fld>
             <a:endParaRPr lang="en-US"/>
           </a:p>
@@ -574,10 +586,9 @@
           <a:lstStyle/>
           <a:p>
             <a:r>
-              <a:rPr lang="en-US" smtClean="0"/>
+              <a:rPr lang="en-US"/>
               <a:t>Click to edit Master title style</a:t>
             </a:r>
-            <a:endParaRPr lang="en-US"/>
           </a:p>
         </p:txBody>
       </p:sp>
@@ -603,38 +614,37 @@
           <a:p>
             <a:pPr lvl="0"/>
             <a:r>
-              <a:rPr lang="en-US" smtClean="0"/>
+              <a:rPr lang="en-US"/>
               <a:t>Click to edit Master text styles</a:t>
             </a:r>
           </a:p>
           <a:p>
             <a:pPr lvl="1"/>
             <a:r>
-              <a:rPr lang="en-US" smtClean="0"/>
+              <a:rPr lang="en-US"/>
               <a:t>Second level</a:t>
             </a:r>
           </a:p>
           <a:p>
             <a:pPr lvl="2"/>
             <a:r>
-              <a:rPr lang="en-US" smtClean="0"/>
+              <a:rPr lang="en-US"/>
               <a:t>Third level</a:t>
             </a:r>
           </a:p>
           <a:p>
             <a:pPr lvl="3"/>
             <a:r>
-              <a:rPr lang="en-US" smtClean="0"/>
+              <a:rPr lang="en-US"/>
               <a:t>Fourth level</a:t>
             </a:r>
           </a:p>
           <a:p>
             <a:pPr lvl="4"/>
             <a:r>
-              <a:rPr lang="en-US" smtClean="0"/>
+              <a:rPr lang="en-US"/>
               <a:t>Fifth level</a:t>
             </a:r>
-            <a:endParaRPr lang="en-US"/>
           </a:p>
         </p:txBody>
       </p:sp>
@@ -655,7 +665,7 @@
           <a:p>
             <a:fld id="{5BCAD085-E8A6-8845-BD4E-CB4CCA059FC4}" type="datetimeFigureOut">
               <a:rPr lang="en-US" smtClean="0"/>
-              <a:t>1/27/13</a:t>
+              <a:t>9/20/2026</a:t>
             </a:fld>
             <a:endParaRPr lang="en-US"/>
           </a:p>
@@ -749,10 +759,9 @@
           <a:lstStyle/>
           <a:p>
             <a:r>
-              <a:rPr lang="en-US" smtClean="0"/>
+              <a:rPr lang="en-US"/>
               <a:t>Click to edit Master title style</a:t>
             </a:r>
-            <a:endParaRPr lang="en-US"/>
           </a:p>
         </p:txBody>
       </p:sp>
@@ -773,38 +782,37 @@
           <a:p>
             <a:pPr lvl="0"/>
             <a:r>
-              <a:rPr lang="en-US" smtClean="0"/>
+              <a:rPr lang="en-US"/>
               <a:t>Click to edit Master text styles</a:t>
             </a:r>
           </a:p>
           <a:p>
             <a:pPr lvl="1"/>
             <a:r>
-              <a:rPr lang="en-US" smtClean="0"/>
+              <a:rPr lang="en-US"/>
               <a:t>Second level</a:t>
             </a:r>
           </a:p>
           <a:p>
             <a:pPr lvl="2"/>
             <a:r>
-              <a:rPr lang="en-US" smtClean="0"/>
+              <a:rPr lang="en-US"/>
               <a:t>Third level</a:t>
             </a:r>
           </a:p>
           <a:p>
             <a:pPr lvl="3"/>
             <a:r>
-              <a:rPr lang="en-US" smtClean="0"/>
+              <a:rPr lang="en-US"/>
               <a:t>Fourth level</a:t>
             </a:r>
           </a:p>
           <a:p>
             <a:pPr lvl="4"/>
             <a:r>
-              <a:rPr lang="en-US" smtClean="0"/>
+              <a:rPr lang="en-US"/>
               <a:t>Fifth level</a:t>
             </a:r>
-            <a:endParaRPr lang="en-US"/>
           </a:p>
         </p:txBody>
       </p:sp>
@@ -825,7 +833,7 @@
           <a:p>
             <a:fld id="{5BCAD085-E8A6-8845-BD4E-CB4CCA059FC4}" type="datetimeFigureOut">
               <a:rPr lang="en-US" smtClean="0"/>
-              <a:t>1/27/13</a:t>
+              <a:t>9/20/2026</a:t>
             </a:fld>
             <a:endParaRPr lang="en-US"/>
           </a:p>
@@ -928,10 +936,9 @@
           </a:lstStyle>
           <a:p>
             <a:r>
-              <a:rPr lang="en-US" smtClean="0"/>
+              <a:rPr lang="en-US"/>
               <a:t>Click to edit Master title style</a:t>
             </a:r>
-            <a:endParaRPr lang="en-US"/>
           </a:p>
         </p:txBody>
       </p:sp>
@@ -1048,7 +1055,7 @@
           <a:p>
             <a:pPr lvl="0"/>
             <a:r>
-              <a:rPr lang="en-US" smtClean="0"/>
+              <a:rPr lang="en-US"/>
               <a:t>Click to edit Master text styles</a:t>
             </a:r>
           </a:p>
@@ -1071,7 +1078,7 @@
           <a:p>
             <a:fld id="{5BCAD085-E8A6-8845-BD4E-CB4CCA059FC4}" type="datetimeFigureOut">
               <a:rPr lang="en-US" smtClean="0"/>
-              <a:t>1/27/13</a:t>
+              <a:t>9/20/2026</a:t>
             </a:fld>
             <a:endParaRPr lang="en-US"/>
           </a:p>
@@ -1165,10 +1172,9 @@
           <a:lstStyle/>
           <a:p>
             <a:r>
-              <a:rPr lang="en-US" smtClean="0"/>
+              <a:rPr lang="en-US"/>
               <a:t>Click to edit Master title style</a:t>
             </a:r>
-            <a:endParaRPr lang="en-US"/>
           </a:p>
         </p:txBody>
       </p:sp>
@@ -1222,38 +1228,37 @@
           <a:p>
             <a:pPr lvl="0"/>
             <a:r>
-              <a:rPr lang="en-US" smtClean="0"/>
+              <a:rPr lang="en-US"/>
               <a:t>Click to edit Master text styles</a:t>
             </a:r>
           </a:p>
           <a:p>
             <a:pPr lvl="1"/>
             <a:r>
-              <a:rPr lang="en-US" smtClean="0"/>
+              <a:rPr lang="en-US"/>
               <a:t>Second level</a:t>
             </a:r>
           </a:p>
           <a:p>
             <a:pPr lvl="2"/>
             <a:r>
-              <a:rPr lang="en-US" smtClean="0"/>
+              <a:rPr lang="en-US"/>
               <a:t>Third level</a:t>
             </a:r>
           </a:p>
           <a:p>
             <a:pPr lvl="3"/>
             <a:r>
-              <a:rPr lang="en-US" smtClean="0"/>
+              <a:rPr lang="en-US"/>
               <a:t>Fourth level</a:t>
             </a:r>
           </a:p>
           <a:p>
             <a:pPr lvl="4"/>
             <a:r>
-              <a:rPr lang="en-US" smtClean="0"/>
+              <a:rPr lang="en-US"/>
               <a:t>Fifth level</a:t>
             </a:r>
-            <a:endParaRPr lang="en-US"/>
           </a:p>
         </p:txBody>
       </p:sp>
@@ -1307,38 +1312,37 @@
           <a:p>
             <a:pPr lvl="0"/>
             <a:r>
-              <a:rPr lang="en-US" smtClean="0"/>
+              <a:rPr lang="en-US"/>
               <a:t>Click to edit Master text styles</a:t>
             </a:r>
           </a:p>
           <a:p>
             <a:pPr lvl="1"/>
             <a:r>
-              <a:rPr lang="en-US" smtClean="0"/>
+              <a:rPr lang="en-US"/>
               <a:t>Second level</a:t>
             </a:r>
           </a:p>
           <a:p>
             <a:pPr lvl="2"/>
             <a:r>
-              <a:rPr lang="en-US" smtClean="0"/>
+              <a:rPr lang="en-US"/>
               <a:t>Third level</a:t>
             </a:r>
           </a:p>
           <a:p>
             <a:pPr lvl="3"/>
             <a:r>
-              <a:rPr lang="en-US" smtClean="0"/>
+              <a:rPr lang="en-US"/>
               <a:t>Fourth level</a:t>
             </a:r>
           </a:p>
           <a:p>
             <a:pPr lvl="4"/>
             <a:r>
-              <a:rPr lang="en-US" smtClean="0"/>
+              <a:rPr lang="en-US"/>
               <a:t>Fifth level</a:t>
             </a:r>
-            <a:endParaRPr lang="en-US"/>
           </a:p>
         </p:txBody>
       </p:sp>
@@ -1359,7 +1363,7 @@
           <a:p>
             <a:fld id="{5BCAD085-E8A6-8845-BD4E-CB4CCA059FC4}" type="datetimeFigureOut">
               <a:rPr lang="en-US" smtClean="0"/>
-              <a:t>1/27/13</a:t>
+              <a:t>9/20/2026</a:t>
             </a:fld>
             <a:endParaRPr lang="en-US"/>
           </a:p>
@@ -1457,10 +1461,9 @@
           </a:lstStyle>
           <a:p>
             <a:r>
-              <a:rPr lang="en-US" smtClean="0"/>
+              <a:rPr lang="en-US"/>
               <a:t>Click to edit Master title style</a:t>
             </a:r>
-            <a:endParaRPr lang="en-US"/>
           </a:p>
         </p:txBody>
       </p:sp>
@@ -1523,7 +1526,7 @@
           <a:p>
             <a:pPr lvl="0"/>
             <a:r>
-              <a:rPr lang="en-US" smtClean="0"/>
+              <a:rPr lang="en-US"/>
               <a:t>Click to edit Master text styles</a:t>
             </a:r>
           </a:p>
@@ -1579,38 +1582,37 @@
           <a:p>
             <a:pPr lvl="0"/>
             <a:r>
-              <a:rPr lang="en-US" smtClean="0"/>
+              <a:rPr lang="en-US"/>
               <a:t>Click to edit Master text styles</a:t>
             </a:r>
           </a:p>
           <a:p>
             <a:pPr lvl="1"/>
             <a:r>
-              <a:rPr lang="en-US" smtClean="0"/>
+              <a:rPr lang="en-US"/>
               <a:t>Second level</a:t>
             </a:r>
           </a:p>
           <a:p>
             <a:pPr lvl="2"/>
             <a:r>
-              <a:rPr lang="en-US" smtClean="0"/>
+              <a:rPr lang="en-US"/>
               <a:t>Third level</a:t>
             </a:r>
           </a:p>
           <a:p>
             <a:pPr lvl="3"/>
             <a:r>
-              <a:rPr lang="en-US" smtClean="0"/>
+              <a:rPr lang="en-US"/>
               <a:t>Fourth level</a:t>
             </a:r>
           </a:p>
           <a:p>
             <a:pPr lvl="4"/>
             <a:r>
-              <a:rPr lang="en-US" smtClean="0"/>
+              <a:rPr lang="en-US"/>
               <a:t>Fifth level</a:t>
             </a:r>
-            <a:endParaRPr lang="en-US"/>
           </a:p>
         </p:txBody>
       </p:sp>
@@ -1673,7 +1675,7 @@
           <a:p>
             <a:pPr lvl="0"/>
             <a:r>
-              <a:rPr lang="en-US" smtClean="0"/>
+              <a:rPr lang="en-US"/>
               <a:t>Click to edit Master text styles</a:t>
             </a:r>
           </a:p>
@@ -1729,38 +1731,37 @@
           <a:p>
             <a:pPr lvl="0"/>
             <a:r>
-              <a:rPr lang="en-US" smtClean="0"/>
+              <a:rPr lang="en-US"/>
               <a:t>Click to edit Master text styles</a:t>
             </a:r>
           </a:p>
           <a:p>
             <a:pPr lvl="1"/>
             <a:r>
-              <a:rPr lang="en-US" smtClean="0"/>
+              <a:rPr lang="en-US"/>
               <a:t>Second level</a:t>
             </a:r>
           </a:p>
           <a:p>
             <a:pPr lvl="2"/>
             <a:r>
-              <a:rPr lang="en-US" smtClean="0"/>
+              <a:rPr lang="en-US"/>
               <a:t>Third level</a:t>
             </a:r>
           </a:p>
           <a:p>
             <a:pPr lvl="3"/>
             <a:r>
-              <a:rPr lang="en-US" smtClean="0"/>
+              <a:rPr lang="en-US"/>
               <a:t>Fourth level</a:t>
             </a:r>
           </a:p>
           <a:p>
             <a:pPr lvl="4"/>
             <a:r>
-              <a:rPr lang="en-US" smtClean="0"/>
+              <a:rPr lang="en-US"/>
               <a:t>Fifth level</a:t>
             </a:r>
-            <a:endParaRPr lang="en-US"/>
           </a:p>
         </p:txBody>
       </p:sp>
@@ -1781,7 +1782,7 @@
           <a:p>
             <a:fld id="{5BCAD085-E8A6-8845-BD4E-CB4CCA059FC4}" type="datetimeFigureOut">
               <a:rPr lang="en-US" smtClean="0"/>
-              <a:t>1/27/13</a:t>
+              <a:t>9/20/2026</a:t>
             </a:fld>
             <a:endParaRPr lang="en-US"/>
           </a:p>
@@ -1875,10 +1876,9 @@
           <a:lstStyle/>
           <a:p>
             <a:r>
-              <a:rPr lang="en-US" smtClean="0"/>
+              <a:rPr lang="en-US"/>
               <a:t>Click to edit Master title style</a:t>
             </a:r>
-            <a:endParaRPr lang="en-US"/>
           </a:p>
         </p:txBody>
       </p:sp>
@@ -1899,7 +1899,7 @@
           <a:p>
             <a:fld id="{5BCAD085-E8A6-8845-BD4E-CB4CCA059FC4}" type="datetimeFigureOut">
               <a:rPr lang="en-US" smtClean="0"/>
-              <a:t>1/27/13</a:t>
+              <a:t>9/20/2026</a:t>
             </a:fld>
             <a:endParaRPr lang="en-US"/>
           </a:p>
@@ -1994,7 +1994,7 @@
           <a:p>
             <a:fld id="{5BCAD085-E8A6-8845-BD4E-CB4CCA059FC4}" type="datetimeFigureOut">
               <a:rPr lang="en-US" smtClean="0"/>
-              <a:t>1/27/13</a:t>
+              <a:t>9/20/2026</a:t>
             </a:fld>
             <a:endParaRPr lang="en-US"/>
           </a:p>
@@ -2097,10 +2097,9 @@
           </a:lstStyle>
           <a:p>
             <a:r>
-              <a:rPr lang="en-US" smtClean="0"/>
+              <a:rPr lang="en-US"/>
               <a:t>Click to edit Master title style</a:t>
             </a:r>
-            <a:endParaRPr lang="en-US"/>
           </a:p>
         </p:txBody>
       </p:sp>
@@ -2154,38 +2153,37 @@
           <a:p>
             <a:pPr lvl="0"/>
             <a:r>
-              <a:rPr lang="en-US" smtClean="0"/>
+              <a:rPr lang="en-US"/>
               <a:t>Click to edit Master text styles</a:t>
             </a:r>
           </a:p>
           <a:p>
             <a:pPr lvl="1"/>
             <a:r>
-              <a:rPr lang="en-US" smtClean="0"/>
+              <a:rPr lang="en-US"/>
               <a:t>Second level</a:t>
             </a:r>
           </a:p>
           <a:p>
             <a:pPr lvl="2"/>
             <a:r>
-              <a:rPr lang="en-US" smtClean="0"/>
+              <a:rPr lang="en-US"/>
               <a:t>Third level</a:t>
             </a:r>
           </a:p>
           <a:p>
             <a:pPr lvl="3"/>
             <a:r>
-              <a:rPr lang="en-US" smtClean="0"/>
+              <a:rPr lang="en-US"/>
               <a:t>Fourth level</a:t>
             </a:r>
           </a:p>
           <a:p>
             <a:pPr lvl="4"/>
             <a:r>
-              <a:rPr lang="en-US" smtClean="0"/>
+              <a:rPr lang="en-US"/>
               <a:t>Fifth level</a:t>
             </a:r>
-            <a:endParaRPr lang="en-US"/>
           </a:p>
         </p:txBody>
       </p:sp>
@@ -2248,7 +2246,7 @@
           <a:p>
             <a:pPr lvl="0"/>
             <a:r>
-              <a:rPr lang="en-US" smtClean="0"/>
+              <a:rPr lang="en-US"/>
               <a:t>Click to edit Master text styles</a:t>
             </a:r>
           </a:p>
@@ -2271,7 +2269,7 @@
           <a:p>
             <a:fld id="{5BCAD085-E8A6-8845-BD4E-CB4CCA059FC4}" type="datetimeFigureOut">
               <a:rPr lang="en-US" smtClean="0"/>
-              <a:t>1/27/13</a:t>
+              <a:t>9/20/2026</a:t>
             </a:fld>
             <a:endParaRPr lang="en-US"/>
           </a:p>
@@ -2374,10 +2372,9 @@
           </a:lstStyle>
           <a:p>
             <a:r>
-              <a:rPr lang="en-US" smtClean="0"/>
+              <a:rPr lang="en-US"/>
               <a:t>Click to edit Master title style</a:t>
             </a:r>
-            <a:endParaRPr lang="en-US"/>
           </a:p>
         </p:txBody>
       </p:sp>
@@ -2501,7 +2498,7 @@
           <a:p>
             <a:pPr lvl="0"/>
             <a:r>
-              <a:rPr lang="en-US" smtClean="0"/>
+              <a:rPr lang="en-US"/>
               <a:t>Click to edit Master text styles</a:t>
             </a:r>
           </a:p>
@@ -2524,7 +2521,7 @@
           <a:p>
             <a:fld id="{5BCAD085-E8A6-8845-BD4E-CB4CCA059FC4}" type="datetimeFigureOut">
               <a:rPr lang="en-US" smtClean="0"/>
-              <a:t>1/27/13</a:t>
+              <a:t>9/20/2026</a:t>
             </a:fld>
             <a:endParaRPr lang="en-US"/>
           </a:p>
@@ -2633,10 +2630,9 @@
           <a:lstStyle/>
           <a:p>
             <a:r>
-              <a:rPr lang="en-US" smtClean="0"/>
+              <a:rPr lang="en-US"/>
               <a:t>Click to edit Master title style</a:t>
             </a:r>
-            <a:endParaRPr lang="en-US"/>
           </a:p>
         </p:txBody>
       </p:sp>
@@ -2667,38 +2663,37 @@
           <a:p>
             <a:pPr lvl="0"/>
             <a:r>
-              <a:rPr lang="en-US" smtClean="0"/>
+              <a:rPr lang="en-US"/>
               <a:t>Click to edit Master text styles</a:t>
             </a:r>
           </a:p>
           <a:p>
             <a:pPr lvl="1"/>
             <a:r>
-              <a:rPr lang="en-US" smtClean="0"/>
+              <a:rPr lang="en-US"/>
               <a:t>Second level</a:t>
             </a:r>
           </a:p>
           <a:p>
             <a:pPr lvl="2"/>
             <a:r>
-              <a:rPr lang="en-US" smtClean="0"/>
+              <a:rPr lang="en-US"/>
               <a:t>Third level</a:t>
             </a:r>
           </a:p>
           <a:p>
             <a:pPr lvl="3"/>
             <a:r>
-              <a:rPr lang="en-US" smtClean="0"/>
+              <a:rPr lang="en-US"/>
               <a:t>Fourth level</a:t>
             </a:r>
           </a:p>
           <a:p>
             <a:pPr lvl="4"/>
             <a:r>
-              <a:rPr lang="en-US" smtClean="0"/>
+              <a:rPr lang="en-US"/>
               <a:t>Fifth level</a:t>
             </a:r>
-            <a:endParaRPr lang="en-US"/>
           </a:p>
         </p:txBody>
       </p:sp>
@@ -2737,7 +2732,7 @@
           <a:p>
             <a:fld id="{5BCAD085-E8A6-8845-BD4E-CB4CCA059FC4}" type="datetimeFigureOut">
               <a:rPr lang="en-US" smtClean="0"/>
-              <a:t>1/27/13</a:t>
+              <a:t>9/20/2026</a:t>
             </a:fld>
             <a:endParaRPr lang="en-US"/>
           </a:p>
@@ -3096,7 +3091,7 @@
 </file>
 
 <file path=ppt/slides/slide1.xml><?xml version="1.0" encoding="utf-8"?>
-<p:sld xmlns:a="http://schemas.openxmlformats.org/drawingml/2006/main" xmlns:p="http://schemas.openxmlformats.org/presentationml/2006/main" xmlns:r="http://schemas.openxmlformats.org/officeDocument/2006/relationships">
+<p:sld xmlns:a="http://schemas.openxmlformats.org/drawingml/2006/main" xmlns:r="http://schemas.openxmlformats.org/officeDocument/2006/relationships" xmlns:p="http://schemas.openxmlformats.org/presentationml/2006/main">
   <p:cSld>
     <p:bg>
       <p:bgPr>
@@ -3112,7 +3107,14 @@
         <p:cNvGrpSpPr/>
         <p:nvPr/>
       </p:nvGrpSpPr>
-      <p:grpSpPr/>
+      <p:grpSpPr>
+        <a:xfrm>
+          <a:off x="0" y="0"/>
+          <a:ext cx="0" cy="0"/>
+          <a:chOff x="0" y="0"/>
+          <a:chExt cx="0" cy="0"/>
+        </a:xfrm>
+      </p:grpSpPr>
       <p:sp>
         <p:nvSpPr>
           <p:cNvPr id="2" name="Rectangle 1"/>
@@ -3153,6 +3155,7 @@
           <a:lstStyle/>
           <a:p>
             <a:pPr algn="ctr"/>
+            <a:endParaRPr/>
           </a:p>
         </p:txBody>
       </p:sp>
@@ -3399,7 +3402,7 @@
 </file>
 
 <file path=ppt/slides/slide10.xml><?xml version="1.0" encoding="utf-8"?>
-<p:sld xmlns:a="http://schemas.openxmlformats.org/drawingml/2006/main" xmlns:p="http://schemas.openxmlformats.org/presentationml/2006/main" xmlns:r="http://schemas.openxmlformats.org/officeDocument/2006/relationships">
+<p:sld xmlns:a="http://schemas.openxmlformats.org/drawingml/2006/main" xmlns:r="http://schemas.openxmlformats.org/officeDocument/2006/relationships" xmlns:p="http://schemas.openxmlformats.org/presentationml/2006/main">
   <p:cSld>
     <p:bg>
       <p:bgPr>
@@ -3415,7 +3418,14 @@
         <p:cNvGrpSpPr/>
         <p:nvPr/>
       </p:nvGrpSpPr>
-      <p:grpSpPr/>
+      <p:grpSpPr>
+        <a:xfrm>
+          <a:off x="0" y="0"/>
+          <a:ext cx="0" cy="0"/>
+          <a:chOff x="0" y="0"/>
+          <a:chExt cx="0" cy="0"/>
+        </a:xfrm>
+      </p:grpSpPr>
       <p:sp>
         <p:nvSpPr>
           <p:cNvPr id="2" name="Rectangle 1"/>
@@ -3456,6 +3466,7 @@
           <a:lstStyle/>
           <a:p>
             <a:pPr algn="ctr"/>
+            <a:endParaRPr/>
           </a:p>
         </p:txBody>
       </p:sp>
@@ -3606,6 +3617,7 @@
           <a:lstStyle/>
           <a:p>
             <a:pPr algn="ctr"/>
+            <a:endParaRPr/>
           </a:p>
         </p:txBody>
       </p:sp>
@@ -3649,6 +3661,7 @@
           <a:lstStyle/>
           <a:p>
             <a:pPr algn="ctr"/>
+            <a:endParaRPr/>
           </a:p>
         </p:txBody>
       </p:sp>
@@ -3711,15 +3724,75 @@
           <a:p>
             <a:pPr algn="ctr"/>
             <a:r>
-              <a:rPr sz="1500" b="0">
+              <a:rPr sz="1500" b="0" dirty="0" err="1">
                 <a:solidFill>
                   <a:srgbClr val="1F1F1F"/>
                 </a:solidFill>
                 <a:latin typeface="Microsoft YaHei"/>
               </a:rPr>
-              <a:t>推理—行动—观察
-工具获取外部事实</a:t>
-            </a:r>
+              <a:t>推理</a:t>
+            </a:r>
+            <a:r>
+              <a:rPr sz="1500" b="0" dirty="0">
+                <a:solidFill>
+                  <a:srgbClr val="1F1F1F"/>
+                </a:solidFill>
+                <a:latin typeface="Microsoft YaHei"/>
+              </a:rPr>
+              <a:t>—</a:t>
+            </a:r>
+            <a:r>
+              <a:rPr sz="1500" b="0" dirty="0" err="1">
+                <a:solidFill>
+                  <a:srgbClr val="1F1F1F"/>
+                </a:solidFill>
+                <a:latin typeface="Microsoft YaHei"/>
+              </a:rPr>
+              <a:t>行动</a:t>
+            </a:r>
+            <a:r>
+              <a:rPr sz="1500" b="0" dirty="0">
+                <a:solidFill>
+                  <a:srgbClr val="1F1F1F"/>
+                </a:solidFill>
+                <a:latin typeface="Microsoft YaHei"/>
+              </a:rPr>
+              <a:t>—</a:t>
+            </a:r>
+            <a:r>
+              <a:rPr sz="1500" b="0" dirty="0" err="1">
+                <a:solidFill>
+                  <a:srgbClr val="1F1F1F"/>
+                </a:solidFill>
+                <a:latin typeface="Microsoft YaHei"/>
+              </a:rPr>
+              <a:t>观察</a:t>
+            </a:r>
+            <a:r>
+              <a:rPr sz="1500" b="0" dirty="0">
+                <a:solidFill>
+                  <a:srgbClr val="1F1F1F"/>
+                </a:solidFill>
+                <a:latin typeface="Microsoft YaHei"/>
+              </a:rPr>
+              <a:t>
+</a:t>
+            </a:r>
+            <a:r>
+              <a:rPr sz="1500" b="0" dirty="0" err="1">
+                <a:solidFill>
+                  <a:srgbClr val="1F1F1F"/>
+                </a:solidFill>
+                <a:latin typeface="Microsoft YaHei"/>
+              </a:rPr>
+              <a:t>工具获取外部事实</a:t>
+            </a:r>
+            <a:endParaRPr sz="1500" b="0" dirty="0">
+              <a:solidFill>
+                <a:srgbClr val="1F1F1F"/>
+              </a:solidFill>
+              <a:latin typeface="Microsoft YaHei"/>
+            </a:endParaRPr>
           </a:p>
         </p:txBody>
       </p:sp>
@@ -3763,6 +3836,7 @@
           <a:lstStyle/>
           <a:p>
             <a:pPr algn="ctr"/>
+            <a:endParaRPr/>
           </a:p>
         </p:txBody>
       </p:sp>
@@ -3808,6 +3882,7 @@
           <a:lstStyle/>
           <a:p>
             <a:pPr algn="ctr"/>
+            <a:endParaRPr/>
           </a:p>
         </p:txBody>
       </p:sp>
@@ -3851,6 +3926,7 @@
           <a:lstStyle/>
           <a:p>
             <a:pPr algn="ctr"/>
+            <a:endParaRPr/>
           </a:p>
         </p:txBody>
       </p:sp>
@@ -3913,14 +3989,32 @@
           <a:p>
             <a:pPr algn="ctr"/>
             <a:r>
-              <a:rPr sz="1500" b="0">
+              <a:rPr sz="1500" b="0" dirty="0">
                 <a:solidFill>
                   <a:srgbClr val="1F1F1F"/>
                 </a:solidFill>
                 <a:latin typeface="Microsoft YaHei"/>
               </a:rPr>
               <a:t>Controller + Expert
-OBSK / JsonRegen / TSC</a:t>
+OBSK / </a:t>
+            </a:r>
+            <a:r>
+              <a:rPr sz="1500" b="0" dirty="0" err="1">
+                <a:solidFill>
+                  <a:srgbClr val="1F1F1F"/>
+                </a:solidFill>
+                <a:latin typeface="Microsoft YaHei"/>
+              </a:rPr>
+              <a:t>JsonRegen</a:t>
+            </a:r>
+            <a:r>
+              <a:rPr sz="1500" b="0" dirty="0">
+                <a:solidFill>
+                  <a:srgbClr val="1F1F1F"/>
+                </a:solidFill>
+                <a:latin typeface="Microsoft YaHei"/>
+              </a:rPr>
+              <a:t> / TSC</a:t>
             </a:r>
           </a:p>
         </p:txBody>
@@ -3965,6 +4059,7 @@
           <a:lstStyle/>
           <a:p>
             <a:pPr algn="ctr"/>
+            <a:endParaRPr/>
           </a:p>
         </p:txBody>
       </p:sp>
@@ -4010,6 +4105,7 @@
           <a:lstStyle/>
           <a:p>
             <a:pPr algn="ctr"/>
+            <a:endParaRPr/>
           </a:p>
         </p:txBody>
       </p:sp>
@@ -4053,6 +4149,7 @@
           <a:lstStyle/>
           <a:p>
             <a:pPr algn="ctr"/>
+            <a:endParaRPr/>
           </a:p>
         </p:txBody>
       </p:sp>
@@ -4115,15 +4212,66 @@
           <a:p>
             <a:pPr algn="ctr"/>
             <a:r>
-              <a:rPr sz="1500" b="0">
+              <a:rPr sz="1500" b="0" dirty="0">
                 <a:solidFill>
                   <a:srgbClr val="1F1F1F"/>
                 </a:solidFill>
                 <a:latin typeface="Microsoft YaHei"/>
               </a:rPr>
-              <a:t>Handler + 多源诊断
-LLM 总结 + 历史检索</a:t>
-            </a:r>
+              <a:t>Handler + </a:t>
+            </a:r>
+            <a:r>
+              <a:rPr sz="1500" b="0" dirty="0" err="1">
+                <a:solidFill>
+                  <a:srgbClr val="1F1F1F"/>
+                </a:solidFill>
+                <a:latin typeface="Microsoft YaHei"/>
+              </a:rPr>
+              <a:t>多源诊断</a:t>
+            </a:r>
+            <a:r>
+              <a:rPr sz="1500" b="0" dirty="0">
+                <a:solidFill>
+                  <a:srgbClr val="1F1F1F"/>
+                </a:solidFill>
+                <a:latin typeface="Microsoft YaHei"/>
+              </a:rPr>
+              <a:t>
+LLM </a:t>
+            </a:r>
+            <a:r>
+              <a:rPr sz="1500" b="0" dirty="0" err="1">
+                <a:solidFill>
+                  <a:srgbClr val="1F1F1F"/>
+                </a:solidFill>
+                <a:latin typeface="Microsoft YaHei"/>
+              </a:rPr>
+              <a:t>总结</a:t>
+            </a:r>
+            <a:r>
+              <a:rPr sz="1500" b="0" dirty="0">
+                <a:solidFill>
+                  <a:srgbClr val="1F1F1F"/>
+                </a:solidFill>
+                <a:latin typeface="Microsoft YaHei"/>
+              </a:rPr>
+              <a:t> + </a:t>
+            </a:r>
+            <a:r>
+              <a:rPr sz="1500" b="0" dirty="0" err="1">
+                <a:solidFill>
+                  <a:srgbClr val="1F1F1F"/>
+                </a:solidFill>
+                <a:latin typeface="Microsoft YaHei"/>
+              </a:rPr>
+              <a:t>历史检索</a:t>
+            </a:r>
+            <a:endParaRPr sz="1500" b="0" dirty="0">
+              <a:solidFill>
+                <a:srgbClr val="1F1F1F"/>
+              </a:solidFill>
+              <a:latin typeface="Microsoft YaHei"/>
+            </a:endParaRPr>
           </a:p>
         </p:txBody>
       </p:sp>
@@ -4167,6 +4315,7 @@
           <a:lstStyle/>
           <a:p>
             <a:pPr algn="ctr"/>
+            <a:endParaRPr/>
           </a:p>
         </p:txBody>
       </p:sp>
@@ -4212,6 +4361,7 @@
           <a:lstStyle/>
           <a:p>
             <a:pPr algn="ctr"/>
+            <a:endParaRPr/>
           </a:p>
         </p:txBody>
       </p:sp>
@@ -4255,6 +4405,7 @@
           <a:lstStyle/>
           <a:p>
             <a:pPr algn="ctr"/>
+            <a:endParaRPr/>
           </a:p>
         </p:txBody>
       </p:sp>
@@ -4317,15 +4468,66 @@
           <a:p>
             <a:pPr algn="ctr"/>
             <a:r>
-              <a:rPr sz="1500" b="0">
+              <a:rPr sz="1500" b="0" dirty="0">
                 <a:solidFill>
                   <a:srgbClr val="1F1F1F"/>
                 </a:solidFill>
                 <a:latin typeface="Microsoft YaHei"/>
               </a:rPr>
-              <a:t>RAG + MCP / 小模型
-Reranker + 结构化报告</a:t>
-            </a:r>
+              <a:t>RAG + MCP / </a:t>
+            </a:r>
+            <a:r>
+              <a:rPr sz="1500" b="0" dirty="0" err="1">
+                <a:solidFill>
+                  <a:srgbClr val="1F1F1F"/>
+                </a:solidFill>
+                <a:latin typeface="Microsoft YaHei"/>
+              </a:rPr>
+              <a:t>小模型</a:t>
+            </a:r>
+            <a:r>
+              <a:rPr sz="1500" b="0" dirty="0">
+                <a:solidFill>
+                  <a:srgbClr val="1F1F1F"/>
+                </a:solidFill>
+                <a:latin typeface="Microsoft YaHei"/>
+              </a:rPr>
+              <a:t>
+</a:t>
+            </a:r>
+            <a:r>
+              <a:rPr sz="1500" b="0" dirty="0" err="1">
+                <a:solidFill>
+                  <a:srgbClr val="1F1F1F"/>
+                </a:solidFill>
+                <a:latin typeface="Microsoft YaHei"/>
+              </a:rPr>
+              <a:t>Reranker</a:t>
+            </a:r>
+            <a:r>
+              <a:rPr sz="1500" b="0" dirty="0">
+                <a:solidFill>
+                  <a:srgbClr val="1F1F1F"/>
+                </a:solidFill>
+                <a:latin typeface="Microsoft YaHei"/>
+              </a:rPr>
+              <a:t> + </a:t>
+            </a:r>
+            <a:r>
+              <a:rPr sz="1500" b="0" dirty="0" err="1">
+                <a:solidFill>
+                  <a:srgbClr val="1F1F1F"/>
+                </a:solidFill>
+                <a:latin typeface="Microsoft YaHei"/>
+              </a:rPr>
+              <a:t>结构化报告</a:t>
+            </a:r>
+            <a:endParaRPr sz="1500" b="0" dirty="0">
+              <a:solidFill>
+                <a:srgbClr val="1F1F1F"/>
+              </a:solidFill>
+              <a:latin typeface="Microsoft YaHei"/>
+            </a:endParaRPr>
           </a:p>
         </p:txBody>
       </p:sp>
@@ -4371,6 +4573,7 @@
           <a:lstStyle/>
           <a:p>
             <a:pPr algn="ctr"/>
+            <a:endParaRPr/>
           </a:p>
         </p:txBody>
       </p:sp>
@@ -4414,6 +4617,7 @@
           <a:lstStyle/>
           <a:p>
             <a:pPr algn="ctr"/>
+            <a:endParaRPr/>
           </a:p>
         </p:txBody>
       </p:sp>
@@ -4496,7 +4700,7 @@
 </file>
 
 <file path=ppt/slides/slide11.xml><?xml version="1.0" encoding="utf-8"?>
-<p:sld xmlns:a="http://schemas.openxmlformats.org/drawingml/2006/main" xmlns:p="http://schemas.openxmlformats.org/presentationml/2006/main" xmlns:r="http://schemas.openxmlformats.org/officeDocument/2006/relationships">
+<p:sld xmlns:a="http://schemas.openxmlformats.org/drawingml/2006/main" xmlns:r="http://schemas.openxmlformats.org/officeDocument/2006/relationships" xmlns:p="http://schemas.openxmlformats.org/presentationml/2006/main">
   <p:cSld>
     <p:spTree>
       <p:nvGrpSpPr>
@@ -4504,7 +4708,14 @@
         <p:cNvGrpSpPr/>
         <p:nvPr/>
       </p:nvGrpSpPr>
-      <p:grpSpPr/>
+      <p:grpSpPr>
+        <a:xfrm>
+          <a:off x="0" y="0"/>
+          <a:ext cx="0" cy="0"/>
+          <a:chOff x="0" y="0"/>
+          <a:chExt cx="0" cy="0"/>
+        </a:xfrm>
+      </p:grpSpPr>
       <p:sp>
         <p:nvSpPr>
           <p:cNvPr id="2" name="Rectangle 1"/>
@@ -4545,6 +4756,7 @@
           <a:lstStyle/>
           <a:p>
             <a:pPr algn="ctr"/>
+            <a:endParaRPr/>
           </a:p>
         </p:txBody>
       </p:sp>
@@ -4660,6 +4872,7 @@
           <a:lstStyle/>
           <a:p>
             <a:pPr algn="ctr"/>
+            <a:endParaRPr/>
           </a:p>
         </p:txBody>
       </p:sp>
@@ -4703,6 +4916,7 @@
           <a:lstStyle/>
           <a:p>
             <a:pPr algn="ctr"/>
+            <a:endParaRPr/>
           </a:p>
         </p:txBody>
       </p:sp>
@@ -4838,6 +5052,7 @@
           <a:lstStyle/>
           <a:p>
             <a:pPr algn="ctr"/>
+            <a:endParaRPr/>
           </a:p>
         </p:txBody>
       </p:sp>
@@ -4881,6 +5096,7 @@
           <a:lstStyle/>
           <a:p>
             <a:pPr algn="ctr"/>
+            <a:endParaRPr/>
           </a:p>
         </p:txBody>
       </p:sp>
@@ -5016,6 +5232,7 @@
           <a:lstStyle/>
           <a:p>
             <a:pPr algn="ctr"/>
+            <a:endParaRPr/>
           </a:p>
         </p:txBody>
       </p:sp>
@@ -5059,6 +5276,7 @@
           <a:lstStyle/>
           <a:p>
             <a:pPr algn="ctr"/>
+            <a:endParaRPr/>
           </a:p>
         </p:txBody>
       </p:sp>
@@ -5214,7 +5432,7 @@
 </file>
 
 <file path=ppt/slides/slide12.xml><?xml version="1.0" encoding="utf-8"?>
-<p:sld xmlns:a="http://schemas.openxmlformats.org/drawingml/2006/main" xmlns:p="http://schemas.openxmlformats.org/presentationml/2006/main" xmlns:r="http://schemas.openxmlformats.org/officeDocument/2006/relationships">
+<p:sld xmlns:a="http://schemas.openxmlformats.org/drawingml/2006/main" xmlns:r="http://schemas.openxmlformats.org/officeDocument/2006/relationships" xmlns:p="http://schemas.openxmlformats.org/presentationml/2006/main">
   <p:cSld>
     <p:bg>
       <p:bgPr>
@@ -5230,7 +5448,14 @@
         <p:cNvGrpSpPr/>
         <p:nvPr/>
       </p:nvGrpSpPr>
-      <p:grpSpPr/>
+      <p:grpSpPr>
+        <a:xfrm>
+          <a:off x="0" y="0"/>
+          <a:ext cx="0" cy="0"/>
+          <a:chOff x="0" y="0"/>
+          <a:chExt cx="0" cy="0"/>
+        </a:xfrm>
+      </p:grpSpPr>
       <p:sp>
         <p:nvSpPr>
           <p:cNvPr id="2" name="Rectangle 1"/>
@@ -5271,6 +5496,7 @@
           <a:lstStyle/>
           <a:p>
             <a:pPr algn="ctr"/>
+            <a:endParaRPr/>
           </a:p>
         </p:txBody>
       </p:sp>
@@ -5414,6 +5640,7 @@
           <a:lstStyle/>
           <a:p>
             <a:pPr algn="ctr"/>
+            <a:endParaRPr/>
           </a:p>
         </p:txBody>
       </p:sp>
@@ -5457,6 +5684,7 @@
           <a:lstStyle/>
           <a:p>
             <a:pPr algn="ctr"/>
+            <a:endParaRPr/>
           </a:p>
         </p:txBody>
       </p:sp>
@@ -5572,6 +5800,7 @@
           <a:lstStyle/>
           <a:p>
             <a:pPr algn="ctr"/>
+            <a:endParaRPr/>
           </a:p>
         </p:txBody>
       </p:sp>
@@ -5615,6 +5844,7 @@
           <a:lstStyle/>
           <a:p>
             <a:pPr algn="ctr"/>
+            <a:endParaRPr/>
           </a:p>
         </p:txBody>
       </p:sp>
@@ -5730,6 +5960,7 @@
           <a:lstStyle/>
           <a:p>
             <a:pPr algn="ctr"/>
+            <a:endParaRPr/>
           </a:p>
         </p:txBody>
       </p:sp>
@@ -5773,6 +6004,7 @@
           <a:lstStyle/>
           <a:p>
             <a:pPr algn="ctr"/>
+            <a:endParaRPr/>
           </a:p>
         </p:txBody>
       </p:sp>
@@ -5890,7 +6122,7 @@
 </file>
 
 <file path=ppt/slides/slide13.xml><?xml version="1.0" encoding="utf-8"?>
-<p:sld xmlns:a="http://schemas.openxmlformats.org/drawingml/2006/main" xmlns:p="http://schemas.openxmlformats.org/presentationml/2006/main" xmlns:r="http://schemas.openxmlformats.org/officeDocument/2006/relationships">
+<p:sld xmlns:a="http://schemas.openxmlformats.org/drawingml/2006/main" xmlns:r="http://schemas.openxmlformats.org/officeDocument/2006/relationships" xmlns:p="http://schemas.openxmlformats.org/presentationml/2006/main">
   <p:cSld>
     <p:bg>
       <p:bgPr>
@@ -5906,7 +6138,14 @@
         <p:cNvGrpSpPr/>
         <p:nvPr/>
       </p:nvGrpSpPr>
-      <p:grpSpPr/>
+      <p:grpSpPr>
+        <a:xfrm>
+          <a:off x="0" y="0"/>
+          <a:ext cx="0" cy="0"/>
+          <a:chOff x="0" y="0"/>
+          <a:chExt cx="0" cy="0"/>
+        </a:xfrm>
+      </p:grpSpPr>
       <p:sp>
         <p:nvSpPr>
           <p:cNvPr id="2" name="Rectangle 1"/>
@@ -5947,6 +6186,7 @@
           <a:lstStyle/>
           <a:p>
             <a:pPr algn="ctr"/>
+            <a:endParaRPr/>
           </a:p>
         </p:txBody>
       </p:sp>
@@ -6090,6 +6330,7 @@
           <a:lstStyle/>
           <a:p>
             <a:pPr algn="ctr"/>
+            <a:endParaRPr/>
           </a:p>
         </p:txBody>
       </p:sp>
@@ -6133,6 +6374,7 @@
           <a:lstStyle/>
           <a:p>
             <a:pPr algn="ctr"/>
+            <a:endParaRPr/>
           </a:p>
         </p:txBody>
       </p:sp>
@@ -6248,6 +6490,7 @@
           <a:lstStyle/>
           <a:p>
             <a:pPr algn="ctr"/>
+            <a:endParaRPr/>
           </a:p>
         </p:txBody>
       </p:sp>
@@ -6291,6 +6534,7 @@
           <a:lstStyle/>
           <a:p>
             <a:pPr algn="ctr"/>
+            <a:endParaRPr/>
           </a:p>
         </p:txBody>
       </p:sp>
@@ -6383,9 +6627,27 @@
                 <a:tableStyleId>{5C22544A-7EE6-4342-B048-85BDC9FD1C3A}</a:tableStyleId>
               </a:tblPr>
               <a:tblGrid>
-                <a:gridCol w="2011680"/>
-                <a:gridCol w="3931920"/>
-                <a:gridCol w="4572000"/>
+                <a:gridCol w="2011680">
+                  <a:extLst>
+                    <a:ext uri="{9D8B030D-6E8A-4147-A177-3AD203B41FA5}">
+                      <a16:colId xmlns:a16="http://schemas.microsoft.com/office/drawing/2014/main" val="20000"/>
+                    </a:ext>
+                  </a:extLst>
+                </a:gridCol>
+                <a:gridCol w="3931920">
+                  <a:extLst>
+                    <a:ext uri="{9D8B030D-6E8A-4147-A177-3AD203B41FA5}">
+                      <a16:colId xmlns:a16="http://schemas.microsoft.com/office/drawing/2014/main" val="20001"/>
+                    </a:ext>
+                  </a:extLst>
+                </a:gridCol>
+                <a:gridCol w="4572000">
+                  <a:extLst>
+                    <a:ext uri="{9D8B030D-6E8A-4147-A177-3AD203B41FA5}">
+                      <a16:colId xmlns:a16="http://schemas.microsoft.com/office/drawing/2014/main" val="20002"/>
+                    </a:ext>
+                  </a:extLst>
+                </a:gridCol>
               </a:tblGrid>
               <a:tr h="475488">
                 <a:tc>
@@ -6460,6 +6722,11 @@
                     </a:solidFill>
                   </a:tcPr>
                 </a:tc>
+                <a:extLst>
+                  <a:ext uri="{0D108BD9-81ED-4DB2-BD59-A6C34878D82A}">
+                    <a16:rowId xmlns:a16="http://schemas.microsoft.com/office/drawing/2014/main" val="10000"/>
+                  </a:ext>
+                </a:extLst>
               </a:tr>
               <a:tr h="475488">
                 <a:tc>
@@ -6534,6 +6801,11 @@
                     </a:solidFill>
                   </a:tcPr>
                 </a:tc>
+                <a:extLst>
+                  <a:ext uri="{0D108BD9-81ED-4DB2-BD59-A6C34878D82A}">
+                    <a16:rowId xmlns:a16="http://schemas.microsoft.com/office/drawing/2014/main" val="10001"/>
+                  </a:ext>
+                </a:extLst>
               </a:tr>
               <a:tr h="475488">
                 <a:tc>
@@ -6608,6 +6880,11 @@
                     </a:solidFill>
                   </a:tcPr>
                 </a:tc>
+                <a:extLst>
+                  <a:ext uri="{0D108BD9-81ED-4DB2-BD59-A6C34878D82A}">
+                    <a16:rowId xmlns:a16="http://schemas.microsoft.com/office/drawing/2014/main" val="10002"/>
+                  </a:ext>
+                </a:extLst>
               </a:tr>
               <a:tr h="475488">
                 <a:tc>
@@ -6682,6 +6959,11 @@
                     </a:solidFill>
                   </a:tcPr>
                 </a:tc>
+                <a:extLst>
+                  <a:ext uri="{0D108BD9-81ED-4DB2-BD59-A6C34878D82A}">
+                    <a16:rowId xmlns:a16="http://schemas.microsoft.com/office/drawing/2014/main" val="10003"/>
+                  </a:ext>
+                </a:extLst>
               </a:tr>
               <a:tr h="475488">
                 <a:tc>
@@ -6756,6 +7038,11 @@
                     </a:solidFill>
                   </a:tcPr>
                 </a:tc>
+                <a:extLst>
+                  <a:ext uri="{0D108BD9-81ED-4DB2-BD59-A6C34878D82A}">
+                    <a16:rowId xmlns:a16="http://schemas.microsoft.com/office/drawing/2014/main" val="10004"/>
+                  </a:ext>
+                </a:extLst>
               </a:tr>
             </a:tbl>
           </a:graphicData>
@@ -6770,7 +7057,7 @@
 </file>
 
 <file path=ppt/slides/slide14.xml><?xml version="1.0" encoding="utf-8"?>
-<p:sld xmlns:a="http://schemas.openxmlformats.org/drawingml/2006/main" xmlns:p="http://schemas.openxmlformats.org/presentationml/2006/main" xmlns:r="http://schemas.openxmlformats.org/officeDocument/2006/relationships">
+<p:sld xmlns:a="http://schemas.openxmlformats.org/drawingml/2006/main" xmlns:r="http://schemas.openxmlformats.org/officeDocument/2006/relationships" xmlns:p="http://schemas.openxmlformats.org/presentationml/2006/main">
   <p:cSld>
     <p:bg>
       <p:bgPr>
@@ -6786,7 +7073,14 @@
         <p:cNvGrpSpPr/>
         <p:nvPr/>
       </p:nvGrpSpPr>
-      <p:grpSpPr/>
+      <p:grpSpPr>
+        <a:xfrm>
+          <a:off x="0" y="0"/>
+          <a:ext cx="0" cy="0"/>
+          <a:chOff x="0" y="0"/>
+          <a:chExt cx="0" cy="0"/>
+        </a:xfrm>
+      </p:grpSpPr>
       <p:sp>
         <p:nvSpPr>
           <p:cNvPr id="2" name="Rectangle 1"/>
@@ -6827,6 +7121,7 @@
           <a:lstStyle/>
           <a:p>
             <a:pPr algn="ctr"/>
+            <a:endParaRPr/>
           </a:p>
         </p:txBody>
       </p:sp>
@@ -6970,6 +7265,7 @@
           <a:lstStyle/>
           <a:p>
             <a:pPr algn="ctr"/>
+            <a:endParaRPr/>
           </a:p>
         </p:txBody>
       </p:sp>
@@ -7013,6 +7309,7 @@
           <a:lstStyle/>
           <a:p>
             <a:pPr algn="ctr"/>
+            <a:endParaRPr/>
           </a:p>
         </p:txBody>
       </p:sp>
@@ -7162,6 +7459,7 @@
           <a:lstStyle/>
           <a:p>
             <a:pPr algn="ctr"/>
+            <a:endParaRPr/>
           </a:p>
         </p:txBody>
       </p:sp>
@@ -7207,6 +7505,7 @@
           <a:lstStyle/>
           <a:p>
             <a:pPr algn="ctr"/>
+            <a:endParaRPr/>
           </a:p>
         </p:txBody>
       </p:sp>
@@ -7250,6 +7549,7 @@
           <a:lstStyle/>
           <a:p>
             <a:pPr algn="ctr"/>
+            <a:endParaRPr/>
           </a:p>
         </p:txBody>
       </p:sp>
@@ -7399,6 +7699,7 @@
           <a:lstStyle/>
           <a:p>
             <a:pPr algn="ctr"/>
+            <a:endParaRPr/>
           </a:p>
         </p:txBody>
       </p:sp>
@@ -7444,6 +7745,7 @@
           <a:lstStyle/>
           <a:p>
             <a:pPr algn="ctr"/>
+            <a:endParaRPr/>
           </a:p>
         </p:txBody>
       </p:sp>
@@ -7487,6 +7789,7 @@
           <a:lstStyle/>
           <a:p>
             <a:pPr algn="ctr"/>
+            <a:endParaRPr/>
           </a:p>
         </p:txBody>
       </p:sp>
@@ -7605,7 +7908,7 @@
 </file>
 
 <file path=ppt/slides/slide15.xml><?xml version="1.0" encoding="utf-8"?>
-<p:sld xmlns:a="http://schemas.openxmlformats.org/drawingml/2006/main" xmlns:p="http://schemas.openxmlformats.org/presentationml/2006/main" xmlns:r="http://schemas.openxmlformats.org/officeDocument/2006/relationships">
+<p:sld xmlns:a="http://schemas.openxmlformats.org/drawingml/2006/main" xmlns:r="http://schemas.openxmlformats.org/officeDocument/2006/relationships" xmlns:p="http://schemas.openxmlformats.org/presentationml/2006/main">
   <p:cSld>
     <p:bg>
       <p:bgPr>
@@ -7621,7 +7924,14 @@
         <p:cNvGrpSpPr/>
         <p:nvPr/>
       </p:nvGrpSpPr>
-      <p:grpSpPr/>
+      <p:grpSpPr>
+        <a:xfrm>
+          <a:off x="0" y="0"/>
+          <a:ext cx="0" cy="0"/>
+          <a:chOff x="0" y="0"/>
+          <a:chExt cx="0" cy="0"/>
+        </a:xfrm>
+      </p:grpSpPr>
       <p:sp>
         <p:nvSpPr>
           <p:cNvPr id="2" name="Rectangle 1"/>
@@ -7662,6 +7972,7 @@
           <a:lstStyle/>
           <a:p>
             <a:pPr algn="ctr"/>
+            <a:endParaRPr/>
           </a:p>
         </p:txBody>
       </p:sp>
@@ -7805,6 +8116,7 @@
           <a:lstStyle/>
           <a:p>
             <a:pPr algn="ctr"/>
+            <a:endParaRPr/>
           </a:p>
         </p:txBody>
       </p:sp>
@@ -7848,6 +8160,7 @@
           <a:lstStyle/>
           <a:p>
             <a:pPr algn="ctr"/>
+            <a:endParaRPr/>
           </a:p>
         </p:txBody>
       </p:sp>
@@ -7961,6 +8274,7 @@
           <a:lstStyle/>
           <a:p>
             <a:pPr algn="ctr"/>
+            <a:endParaRPr/>
           </a:p>
         </p:txBody>
       </p:sp>
@@ -8006,6 +8320,7 @@
           <a:lstStyle/>
           <a:p>
             <a:pPr algn="ctr"/>
+            <a:endParaRPr/>
           </a:p>
         </p:txBody>
       </p:sp>
@@ -8049,6 +8364,7 @@
           <a:lstStyle/>
           <a:p>
             <a:pPr algn="ctr"/>
+            <a:endParaRPr/>
           </a:p>
         </p:txBody>
       </p:sp>
@@ -8162,6 +8478,7 @@
           <a:lstStyle/>
           <a:p>
             <a:pPr algn="ctr"/>
+            <a:endParaRPr/>
           </a:p>
         </p:txBody>
       </p:sp>
@@ -8207,6 +8524,7 @@
           <a:lstStyle/>
           <a:p>
             <a:pPr algn="ctr"/>
+            <a:endParaRPr/>
           </a:p>
         </p:txBody>
       </p:sp>
@@ -8250,6 +8568,7 @@
           <a:lstStyle/>
           <a:p>
             <a:pPr algn="ctr"/>
+            <a:endParaRPr/>
           </a:p>
         </p:txBody>
       </p:sp>
@@ -8363,6 +8682,7 @@
           <a:lstStyle/>
           <a:p>
             <a:pPr algn="ctr"/>
+            <a:endParaRPr/>
           </a:p>
         </p:txBody>
       </p:sp>
@@ -8408,6 +8728,7 @@
           <a:lstStyle/>
           <a:p>
             <a:pPr algn="ctr"/>
+            <a:endParaRPr/>
           </a:p>
         </p:txBody>
       </p:sp>
@@ -8451,6 +8772,7 @@
           <a:lstStyle/>
           <a:p>
             <a:pPr algn="ctr"/>
+            <a:endParaRPr/>
           </a:p>
         </p:txBody>
       </p:sp>
@@ -8564,6 +8886,7 @@
           <a:lstStyle/>
           <a:p>
             <a:pPr algn="ctr"/>
+            <a:endParaRPr/>
           </a:p>
         </p:txBody>
       </p:sp>
@@ -8609,6 +8932,7 @@
           <a:lstStyle/>
           <a:p>
             <a:pPr algn="ctr"/>
+            <a:endParaRPr/>
           </a:p>
         </p:txBody>
       </p:sp>
@@ -8652,6 +8976,7 @@
           <a:lstStyle/>
           <a:p>
             <a:pPr algn="ctr"/>
+            <a:endParaRPr/>
           </a:p>
         </p:txBody>
       </p:sp>
@@ -8765,6 +9090,7 @@
           <a:lstStyle/>
           <a:p>
             <a:pPr algn="ctr"/>
+            <a:endParaRPr/>
           </a:p>
         </p:txBody>
       </p:sp>
@@ -8810,6 +9136,7 @@
           <a:lstStyle/>
           <a:p>
             <a:pPr algn="ctr"/>
+            <a:endParaRPr/>
           </a:p>
         </p:txBody>
       </p:sp>
@@ -8853,6 +9180,7 @@
           <a:lstStyle/>
           <a:p>
             <a:pPr algn="ctr"/>
+            <a:endParaRPr/>
           </a:p>
         </p:txBody>
       </p:sp>
@@ -8966,6 +9294,7 @@
           <a:lstStyle/>
           <a:p>
             <a:pPr algn="ctr"/>
+            <a:endParaRPr/>
           </a:p>
         </p:txBody>
       </p:sp>
@@ -9011,6 +9340,7 @@
           <a:lstStyle/>
           <a:p>
             <a:pPr algn="ctr"/>
+            <a:endParaRPr/>
           </a:p>
         </p:txBody>
       </p:sp>
@@ -9054,6 +9384,7 @@
           <a:lstStyle/>
           <a:p>
             <a:pPr algn="ctr"/>
+            <a:endParaRPr/>
           </a:p>
         </p:txBody>
       </p:sp>
@@ -9204,6 +9535,7 @@
           <a:lstStyle/>
           <a:p>
             <a:pPr algn="ctr"/>
+            <a:endParaRPr/>
           </a:p>
         </p:txBody>
       </p:sp>
@@ -9247,6 +9579,7 @@
           <a:lstStyle/>
           <a:p>
             <a:pPr algn="ctr"/>
+            <a:endParaRPr/>
           </a:p>
         </p:txBody>
       </p:sp>
@@ -9329,7 +9662,7 @@
 </file>
 
 <file path=ppt/slides/slide16.xml><?xml version="1.0" encoding="utf-8"?>
-<p:sld xmlns:a="http://schemas.openxmlformats.org/drawingml/2006/main" xmlns:p="http://schemas.openxmlformats.org/presentationml/2006/main" xmlns:r="http://schemas.openxmlformats.org/officeDocument/2006/relationships">
+<p:sld xmlns:a="http://schemas.openxmlformats.org/drawingml/2006/main" xmlns:r="http://schemas.openxmlformats.org/officeDocument/2006/relationships" xmlns:p="http://schemas.openxmlformats.org/presentationml/2006/main">
   <p:cSld>
     <p:bg>
       <p:bgPr>
@@ -9345,7 +9678,14 @@
         <p:cNvGrpSpPr/>
         <p:nvPr/>
       </p:nvGrpSpPr>
-      <p:grpSpPr/>
+      <p:grpSpPr>
+        <a:xfrm>
+          <a:off x="0" y="0"/>
+          <a:ext cx="0" cy="0"/>
+          <a:chOff x="0" y="0"/>
+          <a:chExt cx="0" cy="0"/>
+        </a:xfrm>
+      </p:grpSpPr>
       <p:sp>
         <p:nvSpPr>
           <p:cNvPr id="2" name="Rectangle 1"/>
@@ -9386,6 +9726,7 @@
           <a:lstStyle/>
           <a:p>
             <a:pPr algn="ctr"/>
+            <a:endParaRPr/>
           </a:p>
         </p:txBody>
       </p:sp>
@@ -9529,6 +9870,7 @@
           <a:lstStyle/>
           <a:p>
             <a:pPr algn="ctr"/>
+            <a:endParaRPr/>
           </a:p>
         </p:txBody>
       </p:sp>
@@ -9572,6 +9914,7 @@
           <a:lstStyle/>
           <a:p>
             <a:pPr algn="ctr"/>
+            <a:endParaRPr/>
           </a:p>
         </p:txBody>
       </p:sp>
@@ -9688,6 +10031,7 @@
           <a:lstStyle/>
           <a:p>
             <a:pPr algn="ctr"/>
+            <a:endParaRPr/>
           </a:p>
         </p:txBody>
       </p:sp>
@@ -9731,6 +10075,7 @@
           <a:lstStyle/>
           <a:p>
             <a:pPr algn="ctr"/>
+            <a:endParaRPr/>
           </a:p>
         </p:txBody>
       </p:sp>
@@ -9847,6 +10192,7 @@
           <a:lstStyle/>
           <a:p>
             <a:pPr algn="ctr"/>
+            <a:endParaRPr/>
           </a:p>
         </p:txBody>
       </p:sp>
@@ -9890,6 +10236,7 @@
           <a:lstStyle/>
           <a:p>
             <a:pPr algn="ctr"/>
+            <a:endParaRPr/>
           </a:p>
         </p:txBody>
       </p:sp>
@@ -10006,6 +10353,7 @@
           <a:lstStyle/>
           <a:p>
             <a:pPr algn="ctr"/>
+            <a:endParaRPr/>
           </a:p>
         </p:txBody>
       </p:sp>
@@ -10049,6 +10397,7 @@
           <a:lstStyle/>
           <a:p>
             <a:pPr algn="ctr"/>
+            <a:endParaRPr/>
           </a:p>
         </p:txBody>
       </p:sp>
@@ -10167,7 +10516,7 @@
 </file>
 
 <file path=ppt/slides/slide17.xml><?xml version="1.0" encoding="utf-8"?>
-<p:sld xmlns:a="http://schemas.openxmlformats.org/drawingml/2006/main" xmlns:p="http://schemas.openxmlformats.org/presentationml/2006/main" xmlns:r="http://schemas.openxmlformats.org/officeDocument/2006/relationships">
+<p:sld xmlns:a="http://schemas.openxmlformats.org/drawingml/2006/main" xmlns:r="http://schemas.openxmlformats.org/officeDocument/2006/relationships" xmlns:p="http://schemas.openxmlformats.org/presentationml/2006/main">
   <p:cSld>
     <p:bg>
       <p:bgPr>
@@ -10183,7 +10532,14 @@
         <p:cNvGrpSpPr/>
         <p:nvPr/>
       </p:nvGrpSpPr>
-      <p:grpSpPr/>
+      <p:grpSpPr>
+        <a:xfrm>
+          <a:off x="0" y="0"/>
+          <a:ext cx="0" cy="0"/>
+          <a:chOff x="0" y="0"/>
+          <a:chExt cx="0" cy="0"/>
+        </a:xfrm>
+      </p:grpSpPr>
       <p:sp>
         <p:nvSpPr>
           <p:cNvPr id="2" name="Rectangle 1"/>
@@ -10224,6 +10580,7 @@
           <a:lstStyle/>
           <a:p>
             <a:pPr algn="ctr"/>
+            <a:endParaRPr/>
           </a:p>
         </p:txBody>
       </p:sp>
@@ -10367,6 +10724,7 @@
           <a:lstStyle/>
           <a:p>
             <a:pPr algn="ctr"/>
+            <a:endParaRPr/>
           </a:p>
         </p:txBody>
       </p:sp>
@@ -10410,6 +10768,7 @@
           <a:lstStyle/>
           <a:p>
             <a:pPr algn="ctr"/>
+            <a:endParaRPr/>
           </a:p>
         </p:txBody>
       </p:sp>
@@ -10526,6 +10885,7 @@
           <a:lstStyle/>
           <a:p>
             <a:pPr algn="ctr"/>
+            <a:endParaRPr/>
           </a:p>
         </p:txBody>
       </p:sp>
@@ -10569,6 +10929,7 @@
           <a:lstStyle/>
           <a:p>
             <a:pPr algn="ctr"/>
+            <a:endParaRPr/>
           </a:p>
         </p:txBody>
       </p:sp>
@@ -10685,6 +11046,7 @@
           <a:lstStyle/>
           <a:p>
             <a:pPr algn="ctr"/>
+            <a:endParaRPr/>
           </a:p>
         </p:txBody>
       </p:sp>
@@ -10728,6 +11090,7 @@
           <a:lstStyle/>
           <a:p>
             <a:pPr algn="ctr"/>
+            <a:endParaRPr/>
           </a:p>
         </p:txBody>
       </p:sp>
@@ -10846,7 +11209,7 @@
 </file>
 
 <file path=ppt/slides/slide18.xml><?xml version="1.0" encoding="utf-8"?>
-<p:sld xmlns:a="http://schemas.openxmlformats.org/drawingml/2006/main" xmlns:p="http://schemas.openxmlformats.org/presentationml/2006/main" xmlns:r="http://schemas.openxmlformats.org/officeDocument/2006/relationships">
+<p:sld xmlns:a="http://schemas.openxmlformats.org/drawingml/2006/main" xmlns:r="http://schemas.openxmlformats.org/officeDocument/2006/relationships" xmlns:p="http://schemas.openxmlformats.org/presentationml/2006/main">
   <p:cSld>
     <p:bg>
       <p:bgPr>
@@ -10862,7 +11225,14 @@
         <p:cNvGrpSpPr/>
         <p:nvPr/>
       </p:nvGrpSpPr>
-      <p:grpSpPr/>
+      <p:grpSpPr>
+        <a:xfrm>
+          <a:off x="0" y="0"/>
+          <a:ext cx="0" cy="0"/>
+          <a:chOff x="0" y="0"/>
+          <a:chExt cx="0" cy="0"/>
+        </a:xfrm>
+      </p:grpSpPr>
       <p:sp>
         <p:nvSpPr>
           <p:cNvPr id="2" name="TextBox 1"/>
@@ -11008,6 +11378,7 @@
           <a:lstStyle/>
           <a:p>
             <a:pPr algn="ctr"/>
+            <a:endParaRPr/>
           </a:p>
         </p:txBody>
       </p:sp>
@@ -11089,7 +11460,7 @@
 </file>
 
 <file path=ppt/slides/slide2.xml><?xml version="1.0" encoding="utf-8"?>
-<p:sld xmlns:a="http://schemas.openxmlformats.org/drawingml/2006/main" xmlns:p="http://schemas.openxmlformats.org/presentationml/2006/main" xmlns:r="http://schemas.openxmlformats.org/officeDocument/2006/relationships">
+<p:sld xmlns:a="http://schemas.openxmlformats.org/drawingml/2006/main" xmlns:r="http://schemas.openxmlformats.org/officeDocument/2006/relationships" xmlns:p="http://schemas.openxmlformats.org/presentationml/2006/main">
   <p:cSld>
     <p:bg>
       <p:bgPr>
@@ -11105,7 +11476,14 @@
         <p:cNvGrpSpPr/>
         <p:nvPr/>
       </p:nvGrpSpPr>
-      <p:grpSpPr/>
+      <p:grpSpPr>
+        <a:xfrm>
+          <a:off x="0" y="0"/>
+          <a:ext cx="0" cy="0"/>
+          <a:chOff x="0" y="0"/>
+          <a:chExt cx="0" cy="0"/>
+        </a:xfrm>
+      </p:grpSpPr>
       <p:sp>
         <p:nvSpPr>
           <p:cNvPr id="2" name="Rectangle 1"/>
@@ -11146,6 +11524,7 @@
           <a:lstStyle/>
           <a:p>
             <a:pPr algn="ctr"/>
+            <a:endParaRPr/>
           </a:p>
         </p:txBody>
       </p:sp>
@@ -11296,6 +11675,7 @@
           <a:lstStyle/>
           <a:p>
             <a:pPr algn="ctr"/>
+            <a:endParaRPr/>
           </a:p>
         </p:txBody>
       </p:sp>
@@ -11339,6 +11719,7 @@
           <a:lstStyle/>
           <a:p>
             <a:pPr algn="ctr"/>
+            <a:endParaRPr/>
           </a:p>
         </p:txBody>
       </p:sp>
@@ -11454,6 +11835,7 @@
           <a:lstStyle/>
           <a:p>
             <a:pPr algn="ctr"/>
+            <a:endParaRPr/>
           </a:p>
         </p:txBody>
       </p:sp>
@@ -11497,6 +11879,7 @@
           <a:lstStyle/>
           <a:p>
             <a:pPr algn="ctr"/>
+            <a:endParaRPr/>
           </a:p>
         </p:txBody>
       </p:sp>
@@ -11612,6 +11995,7 @@
           <a:lstStyle/>
           <a:p>
             <a:pPr algn="ctr"/>
+            <a:endParaRPr/>
           </a:p>
         </p:txBody>
       </p:sp>
@@ -11655,6 +12039,7 @@
           <a:lstStyle/>
           <a:p>
             <a:pPr algn="ctr"/>
+            <a:endParaRPr/>
           </a:p>
         </p:txBody>
       </p:sp>
@@ -11770,6 +12155,7 @@
           <a:lstStyle/>
           <a:p>
             <a:pPr algn="ctr"/>
+            <a:endParaRPr/>
           </a:p>
         </p:txBody>
       </p:sp>
@@ -11813,6 +12199,7 @@
           <a:lstStyle/>
           <a:p>
             <a:pPr algn="ctr"/>
+            <a:endParaRPr/>
           </a:p>
         </p:txBody>
       </p:sp>
@@ -11930,7 +12317,7 @@
 </file>
 
 <file path=ppt/slides/slide3.xml><?xml version="1.0" encoding="utf-8"?>
-<p:sld xmlns:a="http://schemas.openxmlformats.org/drawingml/2006/main" xmlns:p="http://schemas.openxmlformats.org/presentationml/2006/main" xmlns:r="http://schemas.openxmlformats.org/officeDocument/2006/relationships">
+<p:sld xmlns:a="http://schemas.openxmlformats.org/drawingml/2006/main" xmlns:r="http://schemas.openxmlformats.org/officeDocument/2006/relationships" xmlns:p="http://schemas.openxmlformats.org/presentationml/2006/main">
   <p:cSld>
     <p:bg>
       <p:bgPr>
@@ -11946,7 +12333,14 @@
         <p:cNvGrpSpPr/>
         <p:nvPr/>
       </p:nvGrpSpPr>
-      <p:grpSpPr/>
+      <p:grpSpPr>
+        <a:xfrm>
+          <a:off x="0" y="0"/>
+          <a:ext cx="0" cy="0"/>
+          <a:chOff x="0" y="0"/>
+          <a:chExt cx="0" cy="0"/>
+        </a:xfrm>
+      </p:grpSpPr>
       <p:sp>
         <p:nvSpPr>
           <p:cNvPr id="2" name="Rectangle 1"/>
@@ -11987,6 +12381,7 @@
           <a:lstStyle/>
           <a:p>
             <a:pPr algn="ctr"/>
+            <a:endParaRPr/>
           </a:p>
         </p:txBody>
       </p:sp>
@@ -12137,6 +12532,7 @@
           <a:lstStyle/>
           <a:p>
             <a:pPr algn="ctr"/>
+            <a:endParaRPr/>
           </a:p>
         </p:txBody>
       </p:sp>
@@ -12180,6 +12576,7 @@
           <a:lstStyle/>
           <a:p>
             <a:pPr algn="ctr"/>
+            <a:endParaRPr/>
           </a:p>
         </p:txBody>
       </p:sp>
@@ -12295,6 +12692,7 @@
           <a:lstStyle/>
           <a:p>
             <a:pPr algn="ctr"/>
+            <a:endParaRPr/>
           </a:p>
         </p:txBody>
       </p:sp>
@@ -12338,6 +12736,7 @@
           <a:lstStyle/>
           <a:p>
             <a:pPr algn="ctr"/>
+            <a:endParaRPr/>
           </a:p>
         </p:txBody>
       </p:sp>
@@ -12453,6 +12852,7 @@
           <a:lstStyle/>
           <a:p>
             <a:pPr algn="ctr"/>
+            <a:endParaRPr/>
           </a:p>
         </p:txBody>
       </p:sp>
@@ -12496,6 +12896,7 @@
           <a:lstStyle/>
           <a:p>
             <a:pPr algn="ctr"/>
+            <a:endParaRPr/>
           </a:p>
         </p:txBody>
       </p:sp>
@@ -12611,6 +13012,7 @@
           <a:lstStyle/>
           <a:p>
             <a:pPr algn="ctr"/>
+            <a:endParaRPr/>
           </a:p>
         </p:txBody>
       </p:sp>
@@ -12654,6 +13056,7 @@
           <a:lstStyle/>
           <a:p>
             <a:pPr algn="ctr"/>
+            <a:endParaRPr/>
           </a:p>
         </p:txBody>
       </p:sp>
@@ -12736,7 +13139,7 @@
 </file>
 
 <file path=ppt/slides/slide4.xml><?xml version="1.0" encoding="utf-8"?>
-<p:sld xmlns:a="http://schemas.openxmlformats.org/drawingml/2006/main" xmlns:p="http://schemas.openxmlformats.org/presentationml/2006/main" xmlns:r="http://schemas.openxmlformats.org/officeDocument/2006/relationships">
+<p:sld xmlns:a="http://schemas.openxmlformats.org/drawingml/2006/main" xmlns:r="http://schemas.openxmlformats.org/officeDocument/2006/relationships" xmlns:p="http://schemas.openxmlformats.org/presentationml/2006/main">
   <p:cSld>
     <p:bg>
       <p:bgPr>
@@ -12752,7 +13155,14 @@
         <p:cNvGrpSpPr/>
         <p:nvPr/>
       </p:nvGrpSpPr>
-      <p:grpSpPr/>
+      <p:grpSpPr>
+        <a:xfrm>
+          <a:off x="0" y="0"/>
+          <a:ext cx="0" cy="0"/>
+          <a:chOff x="0" y="0"/>
+          <a:chExt cx="0" cy="0"/>
+        </a:xfrm>
+      </p:grpSpPr>
       <p:sp>
         <p:nvSpPr>
           <p:cNvPr id="2" name="Rectangle 1"/>
@@ -12793,6 +13203,7 @@
           <a:lstStyle/>
           <a:p>
             <a:pPr algn="ctr"/>
+            <a:endParaRPr/>
           </a:p>
         </p:txBody>
       </p:sp>
@@ -12943,6 +13354,7 @@
           <a:lstStyle/>
           <a:p>
             <a:pPr algn="ctr"/>
+            <a:endParaRPr/>
           </a:p>
         </p:txBody>
       </p:sp>
@@ -12986,6 +13398,7 @@
           <a:lstStyle/>
           <a:p>
             <a:pPr algn="ctr"/>
+            <a:endParaRPr/>
           </a:p>
         </p:txBody>
       </p:sp>
@@ -13138,6 +13551,7 @@
           <a:lstStyle/>
           <a:p>
             <a:pPr algn="ctr"/>
+            <a:endParaRPr/>
           </a:p>
         </p:txBody>
       </p:sp>
@@ -13181,6 +13595,7 @@
           <a:lstStyle/>
           <a:p>
             <a:pPr algn="ctr"/>
+            <a:endParaRPr/>
           </a:p>
         </p:txBody>
       </p:sp>
@@ -13333,6 +13748,7 @@
           <a:lstStyle/>
           <a:p>
             <a:pPr algn="ctr"/>
+            <a:endParaRPr/>
           </a:p>
         </p:txBody>
       </p:sp>
@@ -13376,6 +13792,7 @@
           <a:lstStyle/>
           <a:p>
             <a:pPr algn="ctr"/>
+            <a:endParaRPr/>
           </a:p>
         </p:txBody>
       </p:sp>
@@ -13527,6 +13944,7 @@
           <a:lstStyle/>
           <a:p>
             <a:pPr algn="ctr"/>
+            <a:endParaRPr/>
           </a:p>
         </p:txBody>
       </p:sp>
@@ -13570,6 +13988,7 @@
           <a:lstStyle/>
           <a:p>
             <a:pPr algn="ctr"/>
+            <a:endParaRPr/>
           </a:p>
         </p:txBody>
       </p:sp>
@@ -13723,7 +14142,7 @@
 </file>
 
 <file path=ppt/slides/slide5.xml><?xml version="1.0" encoding="utf-8"?>
-<p:sld xmlns:a="http://schemas.openxmlformats.org/drawingml/2006/main" xmlns:p="http://schemas.openxmlformats.org/presentationml/2006/main" xmlns:r="http://schemas.openxmlformats.org/officeDocument/2006/relationships">
+<p:sld xmlns:a="http://schemas.openxmlformats.org/drawingml/2006/main" xmlns:r="http://schemas.openxmlformats.org/officeDocument/2006/relationships" xmlns:p="http://schemas.openxmlformats.org/presentationml/2006/main">
   <p:cSld>
     <p:bg>
       <p:bgPr>
@@ -13739,7 +14158,14 @@
         <p:cNvGrpSpPr/>
         <p:nvPr/>
       </p:nvGrpSpPr>
-      <p:grpSpPr/>
+      <p:grpSpPr>
+        <a:xfrm>
+          <a:off x="0" y="0"/>
+          <a:ext cx="0" cy="0"/>
+          <a:chOff x="0" y="0"/>
+          <a:chExt cx="0" cy="0"/>
+        </a:xfrm>
+      </p:grpSpPr>
       <p:sp>
         <p:nvSpPr>
           <p:cNvPr id="2" name="Rectangle 1"/>
@@ -13780,6 +14206,7 @@
           <a:lstStyle/>
           <a:p>
             <a:pPr algn="ctr"/>
+            <a:endParaRPr/>
           </a:p>
         </p:txBody>
       </p:sp>
@@ -13907,10 +14334,34 @@
                 <a:tableStyleId>{5C22544A-7EE6-4342-B048-85BDC9FD1C3A}</a:tableStyleId>
               </a:tblPr>
               <a:tblGrid>
-                <a:gridCol w="2377440"/>
-                <a:gridCol w="3017520"/>
-                <a:gridCol w="2926080"/>
-                <a:gridCol w="2743200"/>
+                <a:gridCol w="2377440">
+                  <a:extLst>
+                    <a:ext uri="{9D8B030D-6E8A-4147-A177-3AD203B41FA5}">
+                      <a16:colId xmlns:a16="http://schemas.microsoft.com/office/drawing/2014/main" val="20000"/>
+                    </a:ext>
+                  </a:extLst>
+                </a:gridCol>
+                <a:gridCol w="3017520">
+                  <a:extLst>
+                    <a:ext uri="{9D8B030D-6E8A-4147-A177-3AD203B41FA5}">
+                      <a16:colId xmlns:a16="http://schemas.microsoft.com/office/drawing/2014/main" val="20001"/>
+                    </a:ext>
+                  </a:extLst>
+                </a:gridCol>
+                <a:gridCol w="2926080">
+                  <a:extLst>
+                    <a:ext uri="{9D8B030D-6E8A-4147-A177-3AD203B41FA5}">
+                      <a16:colId xmlns:a16="http://schemas.microsoft.com/office/drawing/2014/main" val="20002"/>
+                    </a:ext>
+                  </a:extLst>
+                </a:gridCol>
+                <a:gridCol w="2743200">
+                  <a:extLst>
+                    <a:ext uri="{9D8B030D-6E8A-4147-A177-3AD203B41FA5}">
+                      <a16:colId xmlns:a16="http://schemas.microsoft.com/office/drawing/2014/main" val="20003"/>
+                    </a:ext>
+                  </a:extLst>
+                </a:gridCol>
               </a:tblGrid>
               <a:tr h="891540">
                 <a:tc>
@@ -14009,6 +14460,11 @@
                     </a:solidFill>
                   </a:tcPr>
                 </a:tc>
+                <a:extLst>
+                  <a:ext uri="{0D108BD9-81ED-4DB2-BD59-A6C34878D82A}">
+                    <a16:rowId xmlns:a16="http://schemas.microsoft.com/office/drawing/2014/main" val="10000"/>
+                  </a:ext>
+                </a:extLst>
               </a:tr>
               <a:tr h="891540">
                 <a:tc>
@@ -14107,6 +14563,11 @@
                     </a:solidFill>
                   </a:tcPr>
                 </a:tc>
+                <a:extLst>
+                  <a:ext uri="{0D108BD9-81ED-4DB2-BD59-A6C34878D82A}">
+                    <a16:rowId xmlns:a16="http://schemas.microsoft.com/office/drawing/2014/main" val="10001"/>
+                  </a:ext>
+                </a:extLst>
               </a:tr>
               <a:tr h="891540">
                 <a:tc>
@@ -14205,6 +14666,11 @@
                     </a:solidFill>
                   </a:tcPr>
                 </a:tc>
+                <a:extLst>
+                  <a:ext uri="{0D108BD9-81ED-4DB2-BD59-A6C34878D82A}">
+                    <a16:rowId xmlns:a16="http://schemas.microsoft.com/office/drawing/2014/main" val="10002"/>
+                  </a:ext>
+                </a:extLst>
               </a:tr>
               <a:tr h="891540">
                 <a:tc>
@@ -14303,6 +14769,11 @@
                     </a:solidFill>
                   </a:tcPr>
                 </a:tc>
+                <a:extLst>
+                  <a:ext uri="{0D108BD9-81ED-4DB2-BD59-A6C34878D82A}">
+                    <a16:rowId xmlns:a16="http://schemas.microsoft.com/office/drawing/2014/main" val="10003"/>
+                  </a:ext>
+                </a:extLst>
               </a:tr>
             </a:tbl>
           </a:graphicData>
@@ -14352,7 +14823,7 @@
 </file>
 
 <file path=ppt/slides/slide6.xml><?xml version="1.0" encoding="utf-8"?>
-<p:sld xmlns:a="http://schemas.openxmlformats.org/drawingml/2006/main" xmlns:p="http://schemas.openxmlformats.org/presentationml/2006/main" xmlns:r="http://schemas.openxmlformats.org/officeDocument/2006/relationships">
+<p:sld xmlns:a="http://schemas.openxmlformats.org/drawingml/2006/main" xmlns:r="http://schemas.openxmlformats.org/officeDocument/2006/relationships" xmlns:p="http://schemas.openxmlformats.org/presentationml/2006/main">
   <p:cSld>
     <p:bg>
       <p:bgPr>
@@ -14368,7 +14839,14 @@
         <p:cNvGrpSpPr/>
         <p:nvPr/>
       </p:nvGrpSpPr>
-      <p:grpSpPr/>
+      <p:grpSpPr>
+        <a:xfrm>
+          <a:off x="0" y="0"/>
+          <a:ext cx="0" cy="0"/>
+          <a:chOff x="0" y="0"/>
+          <a:chExt cx="0" cy="0"/>
+        </a:xfrm>
+      </p:grpSpPr>
       <p:sp>
         <p:nvSpPr>
           <p:cNvPr id="2" name="Rectangle 1"/>
@@ -14409,6 +14887,7 @@
           <a:lstStyle/>
           <a:p>
             <a:pPr algn="ctr"/>
+            <a:endParaRPr/>
           </a:p>
         </p:txBody>
       </p:sp>
@@ -14559,6 +15038,7 @@
           <a:lstStyle/>
           <a:p>
             <a:pPr algn="ctr"/>
+            <a:endParaRPr/>
           </a:p>
         </p:txBody>
       </p:sp>
@@ -14602,6 +15082,7 @@
           <a:lstStyle/>
           <a:p>
             <a:pPr algn="ctr"/>
+            <a:endParaRPr/>
           </a:p>
         </p:txBody>
       </p:sp>
@@ -14717,6 +15198,7 @@
           <a:lstStyle/>
           <a:p>
             <a:pPr algn="ctr"/>
+            <a:endParaRPr/>
           </a:p>
         </p:txBody>
       </p:sp>
@@ -14760,6 +15242,7 @@
           <a:lstStyle/>
           <a:p>
             <a:pPr algn="ctr"/>
+            <a:endParaRPr/>
           </a:p>
         </p:txBody>
       </p:sp>
@@ -14875,6 +15358,7 @@
           <a:lstStyle/>
           <a:p>
             <a:pPr algn="ctr"/>
+            <a:endParaRPr/>
           </a:p>
         </p:txBody>
       </p:sp>
@@ -14918,6 +15402,7 @@
           <a:lstStyle/>
           <a:p>
             <a:pPr algn="ctr"/>
+            <a:endParaRPr/>
           </a:p>
         </p:txBody>
       </p:sp>
@@ -15033,6 +15518,7 @@
           <a:lstStyle/>
           <a:p>
             <a:pPr algn="ctr"/>
+            <a:endParaRPr/>
           </a:p>
         </p:txBody>
       </p:sp>
@@ -15076,6 +15562,7 @@
           <a:lstStyle/>
           <a:p>
             <a:pPr algn="ctr"/>
+            <a:endParaRPr/>
           </a:p>
         </p:txBody>
       </p:sp>
@@ -15158,7 +15645,7 @@
 </file>
 
 <file path=ppt/slides/slide7.xml><?xml version="1.0" encoding="utf-8"?>
-<p:sld xmlns:a="http://schemas.openxmlformats.org/drawingml/2006/main" xmlns:p="http://schemas.openxmlformats.org/presentationml/2006/main" xmlns:r="http://schemas.openxmlformats.org/officeDocument/2006/relationships">
+<p:sld xmlns:a="http://schemas.openxmlformats.org/drawingml/2006/main" xmlns:r="http://schemas.openxmlformats.org/officeDocument/2006/relationships" xmlns:p="http://schemas.openxmlformats.org/presentationml/2006/main">
   <p:cSld>
     <p:bg>
       <p:bgPr>
@@ -15174,7 +15661,14 @@
         <p:cNvGrpSpPr/>
         <p:nvPr/>
       </p:nvGrpSpPr>
-      <p:grpSpPr/>
+      <p:grpSpPr>
+        <a:xfrm>
+          <a:off x="0" y="0"/>
+          <a:ext cx="0" cy="0"/>
+          <a:chOff x="0" y="0"/>
+          <a:chExt cx="0" cy="0"/>
+        </a:xfrm>
+      </p:grpSpPr>
       <p:sp>
         <p:nvSpPr>
           <p:cNvPr id="2" name="Rectangle 1"/>
@@ -15215,6 +15709,7 @@
           <a:lstStyle/>
           <a:p>
             <a:pPr algn="ctr"/>
+            <a:endParaRPr/>
           </a:p>
         </p:txBody>
       </p:sp>
@@ -15365,6 +15860,7 @@
           <a:lstStyle/>
           <a:p>
             <a:pPr algn="ctr"/>
+            <a:endParaRPr/>
           </a:p>
         </p:txBody>
       </p:sp>
@@ -15408,6 +15904,7 @@
           <a:lstStyle/>
           <a:p>
             <a:pPr algn="ctr"/>
+            <a:endParaRPr/>
           </a:p>
         </p:txBody>
       </p:sp>
@@ -15575,6 +16072,7 @@
           <a:lstStyle/>
           <a:p>
             <a:pPr algn="ctr"/>
+            <a:endParaRPr/>
           </a:p>
         </p:txBody>
       </p:sp>
@@ -15618,6 +16116,7 @@
           <a:lstStyle/>
           <a:p>
             <a:pPr algn="ctr"/>
+            <a:endParaRPr/>
           </a:p>
         </p:txBody>
       </p:sp>
@@ -15785,6 +16284,7 @@
           <a:lstStyle/>
           <a:p>
             <a:pPr algn="ctr"/>
+            <a:endParaRPr/>
           </a:p>
         </p:txBody>
       </p:sp>
@@ -15828,6 +16328,7 @@
           <a:lstStyle/>
           <a:p>
             <a:pPr algn="ctr"/>
+            <a:endParaRPr/>
           </a:p>
         </p:txBody>
       </p:sp>
@@ -15981,7 +16482,7 @@
 </file>
 
 <file path=ppt/slides/slide8.xml><?xml version="1.0" encoding="utf-8"?>
-<p:sld xmlns:a="http://schemas.openxmlformats.org/drawingml/2006/main" xmlns:p="http://schemas.openxmlformats.org/presentationml/2006/main" xmlns:r="http://schemas.openxmlformats.org/officeDocument/2006/relationships">
+<p:sld xmlns:a="http://schemas.openxmlformats.org/drawingml/2006/main" xmlns:r="http://schemas.openxmlformats.org/officeDocument/2006/relationships" xmlns:p="http://schemas.openxmlformats.org/presentationml/2006/main">
   <p:cSld>
     <p:bg>
       <p:bgPr>
@@ -15997,7 +16498,14 @@
         <p:cNvGrpSpPr/>
         <p:nvPr/>
       </p:nvGrpSpPr>
-      <p:grpSpPr/>
+      <p:grpSpPr>
+        <a:xfrm>
+          <a:off x="0" y="0"/>
+          <a:ext cx="0" cy="0"/>
+          <a:chOff x="0" y="0"/>
+          <a:chExt cx="0" cy="0"/>
+        </a:xfrm>
+      </p:grpSpPr>
       <p:sp>
         <p:nvSpPr>
           <p:cNvPr id="2" name="Rectangle 1"/>
@@ -16038,6 +16546,7 @@
           <a:lstStyle/>
           <a:p>
             <a:pPr algn="ctr"/>
+            <a:endParaRPr/>
           </a:p>
         </p:txBody>
       </p:sp>
@@ -16188,6 +16697,7 @@
           <a:lstStyle/>
           <a:p>
             <a:pPr algn="ctr"/>
+            <a:endParaRPr/>
           </a:p>
         </p:txBody>
       </p:sp>
@@ -16231,6 +16741,7 @@
           <a:lstStyle/>
           <a:p>
             <a:pPr algn="ctr"/>
+            <a:endParaRPr/>
           </a:p>
         </p:txBody>
       </p:sp>
@@ -16345,6 +16856,7 @@
           <a:lstStyle/>
           <a:p>
             <a:pPr algn="ctr"/>
+            <a:endParaRPr/>
           </a:p>
         </p:txBody>
       </p:sp>
@@ -16390,6 +16902,7 @@
           <a:lstStyle/>
           <a:p>
             <a:pPr algn="ctr"/>
+            <a:endParaRPr/>
           </a:p>
         </p:txBody>
       </p:sp>
@@ -16433,6 +16946,7 @@
           <a:lstStyle/>
           <a:p>
             <a:pPr algn="ctr"/>
+            <a:endParaRPr/>
           </a:p>
         </p:txBody>
       </p:sp>
@@ -16547,6 +17061,7 @@
           <a:lstStyle/>
           <a:p>
             <a:pPr algn="ctr"/>
+            <a:endParaRPr/>
           </a:p>
         </p:txBody>
       </p:sp>
@@ -16592,6 +17107,7 @@
           <a:lstStyle/>
           <a:p>
             <a:pPr algn="ctr"/>
+            <a:endParaRPr/>
           </a:p>
         </p:txBody>
       </p:sp>
@@ -16635,6 +17151,7 @@
           <a:lstStyle/>
           <a:p>
             <a:pPr algn="ctr"/>
+            <a:endParaRPr/>
           </a:p>
         </p:txBody>
       </p:sp>
@@ -16753,7 +17270,7 @@
 </file>
 
 <file path=ppt/slides/slide9.xml><?xml version="1.0" encoding="utf-8"?>
-<p:sld xmlns:a="http://schemas.openxmlformats.org/drawingml/2006/main" xmlns:p="http://schemas.openxmlformats.org/presentationml/2006/main" xmlns:r="http://schemas.openxmlformats.org/officeDocument/2006/relationships">
+<p:sld xmlns:a="http://schemas.openxmlformats.org/drawingml/2006/main" xmlns:r="http://schemas.openxmlformats.org/officeDocument/2006/relationships" xmlns:p="http://schemas.openxmlformats.org/presentationml/2006/main">
   <p:cSld>
     <p:bg>
       <p:bgPr>
@@ -16769,7 +17286,14 @@
         <p:cNvGrpSpPr/>
         <p:nvPr/>
       </p:nvGrpSpPr>
-      <p:grpSpPr/>
+      <p:grpSpPr>
+        <a:xfrm>
+          <a:off x="0" y="0"/>
+          <a:ext cx="0" cy="0"/>
+          <a:chOff x="0" y="0"/>
+          <a:chExt cx="0" cy="0"/>
+        </a:xfrm>
+      </p:grpSpPr>
       <p:sp>
         <p:nvSpPr>
           <p:cNvPr id="2" name="Rectangle 1"/>
@@ -16810,6 +17334,7 @@
           <a:lstStyle/>
           <a:p>
             <a:pPr algn="ctr"/>
+            <a:endParaRPr/>
           </a:p>
         </p:txBody>
       </p:sp>
@@ -16960,6 +17485,7 @@
           <a:lstStyle/>
           <a:p>
             <a:pPr algn="ctr"/>
+            <a:endParaRPr/>
           </a:p>
         </p:txBody>
       </p:sp>
@@ -17039,6 +17565,7 @@
           <a:lstStyle/>
           <a:p>
             <a:pPr algn="ctr"/>
+            <a:endParaRPr/>
           </a:p>
         </p:txBody>
       </p:sp>
@@ -17084,6 +17611,7 @@
           <a:lstStyle/>
           <a:p>
             <a:pPr algn="ctr"/>
+            <a:endParaRPr/>
           </a:p>
         </p:txBody>
       </p:sp>
@@ -17163,6 +17691,7 @@
           <a:lstStyle/>
           <a:p>
             <a:pPr algn="ctr"/>
+            <a:endParaRPr/>
           </a:p>
         </p:txBody>
       </p:sp>
@@ -17208,6 +17737,7 @@
           <a:lstStyle/>
           <a:p>
             <a:pPr algn="ctr"/>
+            <a:endParaRPr/>
           </a:p>
         </p:txBody>
       </p:sp>
@@ -17287,6 +17817,7 @@
           <a:lstStyle/>
           <a:p>
             <a:pPr algn="ctr"/>
+            <a:endParaRPr/>
           </a:p>
         </p:txBody>
       </p:sp>
@@ -17332,6 +17863,7 @@
           <a:lstStyle/>
           <a:p>
             <a:pPr algn="ctr"/>
+            <a:endParaRPr/>
           </a:p>
         </p:txBody>
       </p:sp>
@@ -17411,6 +17943,7 @@
           <a:lstStyle/>
           <a:p>
             <a:pPr algn="ctr"/>
+            <a:endParaRPr/>
           </a:p>
         </p:txBody>
       </p:sp>
@@ -17456,6 +17989,7 @@
           <a:lstStyle/>
           <a:p>
             <a:pPr algn="ctr"/>
+            <a:endParaRPr/>
           </a:p>
         </p:txBody>
       </p:sp>
@@ -17535,6 +18069,7 @@
           <a:lstStyle/>
           <a:p>
             <a:pPr algn="ctr"/>
+            <a:endParaRPr/>
           </a:p>
         </p:txBody>
       </p:sp>
@@ -17580,6 +18115,7 @@
           <a:lstStyle/>
           <a:p>
             <a:pPr algn="ctr"/>
+            <a:endParaRPr/>
           </a:p>
         </p:txBody>
       </p:sp>
@@ -17696,6 +18232,7 @@
           <a:lstStyle/>
           <a:p>
             <a:pPr algn="ctr"/>
+            <a:endParaRPr/>
           </a:p>
         </p:txBody>
       </p:sp>
@@ -17739,6 +18276,7 @@
           <a:lstStyle/>
           <a:p>
             <a:pPr algn="ctr"/>
+            <a:endParaRPr/>
           </a:p>
         </p:txBody>
       </p:sp>

</xml_diff>